<commit_message>
Restyle class work files in black, white and blue
Co-Authored-By: Claude Opus 5.5 <noreply@anthropic.com>
Claude-Session: https://claude.ai/code/session_01ViSVrkfNYmVSDoY4z54Vze
</commit_message>
<xml_diff>
--- a/research-register/ChatGPT_Claude_Courses_Presentation.pptx
+++ b/research-register/ChatGPT_Claude_Courses_Presentation.pptx
@@ -113,13 +113,13 @@
   <p:extLst>
     <p:ext uri="{521415D9-36F7-43E2-AB2F-B90AF26B5E84}">
       <p14:sectionLst xmlns:p14="http://schemas.microsoft.com/office/powerpoint/2010/main">
-        <p14:section name="Introduction" id="{afdd759a-cfdd-e798-4a4c-c8a0e592f9a8}">
+        <p14:section name="Introduction" id="{440fc2e4-4803-0ced-68f0-cbf9e15d032e}">
           <p14:sldIdLst>
             <p14:sldId id="256"/>
             <p14:sldId id="257"/>
           </p14:sldIdLst>
         </p14:section>
-        <p14:section name="Findings" id="{577f94ee-a199-cc8c-72d9-ff28abb01510}">
+        <p14:section name="Findings" id="{27d9fc45-30bf-219a-de58-b41842784d3d}">
           <p14:sldIdLst>
             <p14:sldId id="258"/>
             <p14:sldId id="259"/>
@@ -127,7 +127,7 @@
             <p14:sldId id="261"/>
           </p14:sldIdLst>
         </p14:section>
-        <p14:section name="Sources" id="{cd9cd689-6838-1a96-e939-78daa9a165a8}">
+        <p14:section name="Sources" id="{6034bd09-76be-8814-5eef-9f66d1af7ff3}">
           <p14:sldIdLst>
             <p14:sldId id="262"/>
           </p14:sldIdLst>
@@ -155,7 +155,7 @@
             <a:pPr>
               <a:defRPr sz="1400" b="0" i="0" u="none" strike="noStrike">
                 <a:solidFill>
-                  <a:srgbClr val="5B6B73"/>
+                  <a:srgbClr val="3F3F46"/>
                 </a:solidFill>
                 <a:latin typeface="+mn-lt"/>
               </a:defRPr>
@@ -163,7 +163,7 @@
             <a:r>
               <a:rPr sz="1400" b="0" i="0" u="none" strike="noStrike">
                 <a:solidFill>
-                  <a:srgbClr val="5B6B73"/>
+                  <a:srgbClr val="3F3F46"/>
                 </a:solidFill>
                 <a:latin typeface="+mn-lt"/>
               </a:rPr>
@@ -198,7 +198,7 @@
           </c:tx>
           <c:spPr>
             <a:solidFill>
-              <a:srgbClr val="10A37F"/>
+              <a:srgbClr val="1A56DB"/>
             </a:solidFill>
             <a:effectLst/>
           </c:spPr>
@@ -212,7 +212,7 @@
                 <a:pPr>
                   <a:defRPr b="1" i="0" strike="noStrike" sz="1400" u="none">
                     <a:solidFill>
-                      <a:srgbClr val="1F2328"/>
+                      <a:srgbClr val="000000"/>
                     </a:solidFill>
                     <a:latin typeface="+mn-lt"/>
                   </a:defRPr>
@@ -233,7 +233,7 @@
             <c:bubble3D val="0"/>
             <c:spPr>
               <a:solidFill>
-                <a:srgbClr val="10A37F"/>
+                <a:srgbClr val="1A56DB"/>
               </a:solidFill>
               <a:effectLst/>
             </c:spPr>
@@ -244,7 +244,7 @@
             <c:bubble3D val="0"/>
             <c:spPr>
               <a:solidFill>
-                <a:srgbClr val="10A37F"/>
+                <a:srgbClr val="1A56DB"/>
               </a:solidFill>
               <a:effectLst/>
             </c:spPr>
@@ -255,7 +255,7 @@
             <c:bubble3D val="0"/>
             <c:spPr>
               <a:solidFill>
-                <a:srgbClr val="D97757"/>
+                <a:srgbClr val="111111"/>
               </a:solidFill>
               <a:effectLst/>
             </c:spPr>
@@ -266,7 +266,7 @@
             <c:bubble3D val="0"/>
             <c:spPr>
               <a:solidFill>
-                <a:srgbClr val="D97757"/>
+                <a:srgbClr val="111111"/>
               </a:solidFill>
               <a:effectLst/>
             </c:spPr>
@@ -277,7 +277,7 @@
             <c:bubble3D val="0"/>
             <c:spPr>
               <a:solidFill>
-                <a:srgbClr val="D97757"/>
+                <a:srgbClr val="111111"/>
               </a:solidFill>
               <a:effectLst/>
             </c:spPr>
@@ -341,7 +341,7 @@
               <a:pPr>
                 <a:defRPr b="1" i="0" strike="noStrike" sz="1400" u="none">
                   <a:solidFill>
-                    <a:srgbClr val="1F2328"/>
+                    <a:srgbClr val="000000"/>
                   </a:solidFill>
                   <a:latin typeface="+mn-lt"/>
                 </a:defRPr>
@@ -389,7 +389,7 @@
             <a:pPr>
               <a:defRPr sz="1300" b="0" i="0" u="none" strike="noStrike">
                 <a:solidFill>
-                  <a:srgbClr val="1F2328"/>
+                  <a:srgbClr val="000000"/>
                 </a:solidFill>
                 <a:latin typeface="+mn-lt"/>
               </a:defRPr>
@@ -2191,11 +2191,11 @@
             <a:avLst/>
           </a:prstGeom>
           <a:solidFill>
-            <a:schemeClr val="accent2"/>
+            <a:schemeClr val="bg1"/>
           </a:solidFill>
           <a:ln w="12700">
             <a:solidFill>
-              <a:schemeClr val="accent2"/>
+              <a:schemeClr val="bg1"/>
             </a:solidFill>
             <a:prstDash val="solid"/>
           </a:ln>
@@ -5608,7 +5608,7 @@
                       <a:r>
                         <a:rPr lang="en-US" sz="1300" b="1" dirty="0">
                           <a:solidFill>
-                            <a:schemeClr val="accent4"/>
+                            <a:schemeClr val="tx1"/>
                           </a:solidFill>
                         </a:rPr>
                         <a:t>−5,482</a:t>
@@ -6159,7 +6159,7 @@
                       <a:r>
                         <a:rPr lang="en-US" sz="1300" b="1" dirty="0">
                           <a:solidFill>
-                            <a:schemeClr val="accent4"/>
+                            <a:schemeClr val="tx1"/>
                           </a:solidFill>
                         </a:rPr>
                         <a:t>−8,162</a:t>
@@ -6710,7 +6710,7 @@
                       <a:r>
                         <a:rPr lang="en-US" sz="1300" b="1" dirty="0">
                           <a:solidFill>
-                            <a:schemeClr val="accent4"/>
+                            <a:schemeClr val="tx1"/>
                           </a:solidFill>
                         </a:rPr>
                         <a:t>−461</a:t>
@@ -8205,7 +8205,7 @@
             <a:r>
               <a:rPr lang="en-US" sz="1400" u="sng" dirty="0">
                 <a:solidFill>
-                  <a:srgbClr val="0B6E99"/>
+                  <a:srgbClr val="000000"/>
                 </a:solidFill>
                 <a:hlinkClick r:id="rId1" invalidUrl="" action="" tgtFrame="" tooltip="" history="1" highlightClick="0" endSnd="0">
                   <a:extLst>
@@ -8243,7 +8243,7 @@
             <a:r>
               <a:rPr lang="en-US" sz="1400" u="sng" dirty="0">
                 <a:solidFill>
-                  <a:srgbClr val="0B6E99"/>
+                  <a:srgbClr val="000000"/>
                 </a:solidFill>
                 <a:hlinkClick r:id="rId2" invalidUrl="" action="" tgtFrame="" tooltip="" history="1" highlightClick="0" endSnd="0">
                   <a:extLst>
@@ -8281,7 +8281,7 @@
             <a:r>
               <a:rPr lang="en-US" sz="1400" u="sng" dirty="0">
                 <a:solidFill>
-                  <a:srgbClr val="0B6E99"/>
+                  <a:srgbClr val="000000"/>
                 </a:solidFill>
                 <a:hlinkClick r:id="rId3" invalidUrl="" action="" tgtFrame="" tooltip="" history="1" highlightClick="0" endSnd="0">
                   <a:extLst>
@@ -8319,7 +8319,7 @@
             <a:r>
               <a:rPr lang="en-US" sz="1400" u="sng" dirty="0">
                 <a:solidFill>
-                  <a:srgbClr val="0B6E99"/>
+                  <a:srgbClr val="000000"/>
                 </a:solidFill>
                 <a:hlinkClick r:id="rId4" invalidUrl="" action="" tgtFrame="" tooltip="" history="1" highlightClick="0" endSnd="0">
                   <a:extLst>
@@ -8357,7 +8357,7 @@
             <a:r>
               <a:rPr lang="en-US" sz="1400" u="sng" dirty="0">
                 <a:solidFill>
-                  <a:srgbClr val="0B6E99"/>
+                  <a:srgbClr val="000000"/>
                 </a:solidFill>
                 <a:hlinkClick r:id="rId5" invalidUrl="" action="" tgtFrame="" tooltip="" history="1" highlightClick="0" endSnd="0">
                   <a:extLst>
@@ -8570,40 +8570,40 @@
   <a:themeElements>
     <a:clrScheme name="ChatGPT Claude Register">
       <a:dk1>
-        <a:srgbClr val="1F2328"/>
+        <a:srgbClr val="000000"/>
       </a:dk1>
       <a:lt1>
         <a:srgbClr val="FFFFFF"/>
       </a:lt1>
       <a:dk2>
-        <a:srgbClr val="1E2A32"/>
+        <a:srgbClr val="0A0A0A"/>
       </a:dk2>
       <a:lt2>
-        <a:srgbClr val="EEF3F1"/>
+        <a:srgbClr val="EEF4FF"/>
       </a:lt2>
       <a:accent1>
-        <a:srgbClr val="10A37F"/>
+        <a:srgbClr val="1A56DB"/>
       </a:accent1>
       <a:accent2>
-        <a:srgbClr val="D97757"/>
+        <a:srgbClr val="111111"/>
       </a:accent2>
       <a:accent3>
-        <a:srgbClr val="5B6B73"/>
+        <a:srgbClr val="3F3F46"/>
       </a:accent3>
       <a:accent4>
-        <a:srgbClr val="C0392B"/>
+        <a:srgbClr val="0B3D91"/>
       </a:accent4>
       <a:accent5>
-        <a:srgbClr val="7FC8B4"/>
+        <a:srgbClr val="8AB4F8"/>
       </a:accent5>
       <a:accent6>
-        <a:srgbClr val="F0B9A4"/>
+        <a:srgbClr val="C7D7F9"/>
       </a:accent6>
       <a:hlink>
-        <a:srgbClr val="0B6E99"/>
+        <a:srgbClr val="1A56DB"/>
       </a:hlink>
       <a:folHlink>
-        <a:srgbClr val="6B4E9B"/>
+        <a:srgbClr val="0B3D91"/>
       </a:folHlink>
     </a:clrScheme>
     <a:fontScheme name="ChatGPT Claude Register">

</xml_diff>